<commit_message>
allow keypresses on no-response trials
</commit_message>
<xml_diff>
--- a/Task/Stimuli/Instructions/Instructions.pptx
+++ b/Task/Stimuli/Instructions/Instructions.pptx
@@ -4339,7 +4339,7 @@
         <p:spPr>
           <a:xfrm>
             <a:off x="650009" y="654162"/>
-            <a:ext cx="11146420" cy="2031325"/>
+            <a:ext cx="11146420" cy="1754326"/>
           </a:xfrm>
           <a:prstGeom prst="rect">
             <a:avLst/>
@@ -4384,19 +4384,6 @@
                 <a:cs typeface="Arial" panose="020B0604020202020204" pitchFamily="34" charset="0"/>
               </a:rPr>
               <a:t>In this experiment, we will show you pairs of images presented one after the other. </a:t>
-            </a:r>
-          </a:p>
-          <a:p>
-            <a:pPr algn="ctr"/>
-            <a:r>
-              <a:rPr lang="en-US" dirty="0">
-                <a:solidFill>
-                  <a:schemeClr val="bg1"/>
-                </a:solidFill>
-                <a:latin typeface="Arial" panose="020B0604020202020204" pitchFamily="34" charset="0"/>
-                <a:cs typeface="Arial" panose="020B0604020202020204" pitchFamily="34" charset="0"/>
-              </a:rPr>
-              <a:t>Your task is to decide which one is the Correct one. </a:t>
             </a:r>
           </a:p>
           <a:p>

</xml_diff>